<commit_message>
deck(template-fill): tokenize slide 4 (margin) + wire CURRENT_MARGIN/GP_PER_POINT tokens; fill verified
</commit_message>
<xml_diff>
--- a/board-template/U1Dynamics_Board_Template_TOKENIZED.pptx
+++ b/board-template/U1Dynamics_Board_Template_TOKENIZED.pptx
@@ -12629,6 +12629,10 @@
             <a:prstDash val="solid"/>
           </a:ln>
         </p:spPr>
+        <p:txBody>
+          <a:bodyPr/>
+          <a:p/>
+        </p:txBody>
       </p:sp>
       <p:sp>
         <p:nvSpPr>
@@ -12656,6 +12660,10 @@
             <a:prstDash val="solid"/>
           </a:ln>
         </p:spPr>
+        <p:txBody>
+          <a:bodyPr/>
+          <a:p/>
+        </p:txBody>
       </p:sp>
       <p:sp>
         <p:nvSpPr>
@@ -12733,7 +12741,7 @@
                 <a:ea typeface="Aptos Display" pitchFamily="34" charset="-122"/>
                 <a:cs typeface="Aptos Display" pitchFamily="34" charset="-120"/>
               </a:rPr>
-              <a:t>18.2%</a:t>
+              <a:t>{{GROSS_MARGIN}}</a:t>
             </a:r>
             <a:endParaRPr lang="en-US" sz="2600" dirty="0"/>
           </a:p>
@@ -12806,6 +12814,10 @@
             <a:prstDash val="solid"/>
           </a:ln>
         </p:spPr>
+        <p:txBody>
+          <a:bodyPr/>
+          <a:p/>
+        </p:txBody>
       </p:sp>
       <p:sp>
         <p:nvSpPr>
@@ -12883,7 +12895,7 @@
                 <a:ea typeface="Aptos Display" pitchFamily="34" charset="-122"/>
                 <a:cs typeface="Aptos Display" pitchFamily="34" charset="-120"/>
               </a:rPr>
-              <a:t>19.6%</a:t>
+              <a:t>{{CURRENT_MARGIN}}</a:t>
             </a:r>
             <a:endParaRPr lang="en-US" sz="2600" dirty="0"/>
           </a:p>
@@ -12956,6 +12968,10 @@
             <a:prstDash val="solid"/>
           </a:ln>
         </p:spPr>
+        <p:txBody>
+          <a:bodyPr/>
+          <a:p/>
+        </p:txBody>
       </p:sp>
       <p:sp>
         <p:nvSpPr>
@@ -13033,7 +13049,7 @@
                 <a:ea typeface="Aptos Display" pitchFamily="34" charset="-122"/>
                 <a:cs typeface="Aptos Display" pitchFamily="34" charset="-120"/>
               </a:rPr>
-              <a:t>≈$95K</a:t>
+              <a:t>≈{{GP_PER_POINT}}</a:t>
             </a:r>
             <a:endParaRPr lang="en-US" sz="2600" dirty="0"/>
           </a:p>
@@ -13106,6 +13122,10 @@
             <a:prstDash val="solid"/>
           </a:ln>
         </p:spPr>
+        <p:txBody>
+          <a:bodyPr/>
+          <a:p/>
+        </p:txBody>
       </p:sp>
       <p:sp>
         <p:nvSpPr>
@@ -13336,6 +13356,10 @@
             <a:prstDash val="solid"/>
           </a:ln>
         </p:spPr>
+        <p:txBody>
+          <a:bodyPr/>
+          <a:p/>
+        </p:txBody>
       </p:sp>
       <p:sp>
         <p:nvSpPr>
@@ -13361,6 +13385,10 @@
             <a:prstDash val="solid"/>
           </a:ln>
         </p:spPr>
+        <p:txBody>
+          <a:bodyPr/>
+          <a:p/>
+        </p:txBody>
       </p:sp>
       <p:sp>
         <p:nvSpPr>
@@ -13397,7 +13425,7 @@
                 <a:ea typeface="Aptos" pitchFamily="34" charset="-122"/>
                 <a:cs typeface="Aptos" pitchFamily="34" charset="-120"/>
               </a:rPr>
-              <a:t>18.2%</a:t>
+              <a:t>{{GROSS_MARGIN}}</a:t>
             </a:r>
             <a:endParaRPr lang="en-US" sz="580" dirty="0"/>
           </a:p>
@@ -13425,6 +13453,10 @@
             <a:prstDash val="solid"/>
           </a:ln>
         </p:spPr>
+        <p:txBody>
+          <a:bodyPr/>
+          <a:p/>
+        </p:txBody>
       </p:sp>
       <p:sp>
         <p:nvSpPr>
@@ -13577,6 +13609,10 @@
             <a:prstDash val="solid"/>
           </a:ln>
         </p:spPr>
+        <p:txBody>
+          <a:bodyPr/>
+          <a:p/>
+        </p:txBody>
       </p:sp>
       <p:sp>
         <p:nvSpPr>
@@ -13686,6 +13722,10 @@
             <a:prstDash val="solid"/>
           </a:ln>
         </p:spPr>
+        <p:txBody>
+          <a:bodyPr/>
+          <a:p/>
+        </p:txBody>
       </p:sp>
       <p:sp>
         <p:nvSpPr>
@@ -13791,6 +13831,10 @@
             <a:prstDash val="solid"/>
           </a:ln>
         </p:spPr>
+        <p:txBody>
+          <a:bodyPr/>
+          <a:p/>
+        </p:txBody>
       </p:sp>
       <p:sp>
         <p:nvSpPr>

</xml_diff>

<commit_message>
deck(template-fill): tokenize slide 6 (top-5 accounts: names + shares); fill verified
</commit_message>
<xml_diff>
--- a/board-template/U1Dynamics_Board_Template_TOKENIZED.pptx
+++ b/board-template/U1Dynamics_Board_Template_TOKENIZED.pptx
@@ -15212,6 +15212,10 @@
             <a:prstDash val="solid"/>
           </a:ln>
         </p:spPr>
+        <p:txBody>
+          <a:bodyPr/>
+          <a:p/>
+        </p:txBody>
       </p:sp>
       <p:sp>
         <p:nvSpPr>
@@ -15289,7 +15293,7 @@
                 <a:ea typeface="Aptos" pitchFamily="34" charset="-122"/>
                 <a:cs typeface="Aptos" pitchFamily="34" charset="-120"/>
               </a:rPr>
-              <a:t>U1Dynamics Mfg · intercompany</a:t>
+              <a:t>{{ACCT1_NAME}}</a:t>
             </a:r>
             <a:endParaRPr lang="en-US" sz="800" dirty="0"/>
           </a:p>
@@ -15319,6 +15323,10 @@
             <a:prstDash val="solid"/>
           </a:ln>
         </p:spPr>
+        <p:txBody>
+          <a:bodyPr/>
+          <a:p/>
+        </p:txBody>
       </p:sp>
       <p:sp>
         <p:nvSpPr>
@@ -15344,6 +15352,10 @@
             <a:prstDash val="solid"/>
           </a:ln>
         </p:spPr>
+        <p:txBody>
+          <a:bodyPr/>
+          <a:p/>
+        </p:txBody>
       </p:sp>
       <p:sp>
         <p:nvSpPr>
@@ -15380,7 +15392,7 @@
                 <a:ea typeface="Aptos" pitchFamily="34" charset="-122"/>
                 <a:cs typeface="Aptos" pitchFamily="34" charset="-120"/>
               </a:rPr>
-              <a:t>42.2%</a:t>
+              <a:t>{{ACCT1_SHARE}}</a:t>
             </a:r>
             <a:endParaRPr lang="en-US" sz="770" dirty="0"/>
           </a:p>
@@ -15421,7 +15433,7 @@
                 <a:ea typeface="Aptos" pitchFamily="34" charset="-122"/>
                 <a:cs typeface="Aptos" pitchFamily="34" charset="-120"/>
               </a:rPr>
-              <a:t>8A Dominus Inc.</a:t>
+              <a:t>{{ACCT2_NAME}}</a:t>
             </a:r>
             <a:endParaRPr lang="en-US" sz="800" dirty="0"/>
           </a:p>
@@ -15451,6 +15463,10 @@
             <a:prstDash val="solid"/>
           </a:ln>
         </p:spPr>
+        <p:txBody>
+          <a:bodyPr/>
+          <a:p/>
+        </p:txBody>
       </p:sp>
       <p:sp>
         <p:nvSpPr>
@@ -15476,6 +15492,10 @@
             <a:prstDash val="solid"/>
           </a:ln>
         </p:spPr>
+        <p:txBody>
+          <a:bodyPr/>
+          <a:p/>
+        </p:txBody>
       </p:sp>
       <p:sp>
         <p:nvSpPr>
@@ -15512,7 +15532,7 @@
                 <a:ea typeface="Aptos" pitchFamily="34" charset="-122"/>
                 <a:cs typeface="Aptos" pitchFamily="34" charset="-120"/>
               </a:rPr>
-              <a:t>13.2%</a:t>
+              <a:t>{{ACCT2_SHARE}}</a:t>
             </a:r>
             <a:endParaRPr lang="en-US" sz="770" dirty="0"/>
           </a:p>
@@ -15553,7 +15573,7 @@
                 <a:ea typeface="Aptos" pitchFamily="34" charset="-122"/>
                 <a:cs typeface="Aptos" pitchFamily="34" charset="-120"/>
               </a:rPr>
-              <a:t>Competitive Edge Dist.</a:t>
+              <a:t>{{ACCT3_NAME}}</a:t>
             </a:r>
             <a:endParaRPr lang="en-US" sz="800" dirty="0"/>
           </a:p>
@@ -15583,6 +15603,10 @@
             <a:prstDash val="solid"/>
           </a:ln>
         </p:spPr>
+        <p:txBody>
+          <a:bodyPr/>
+          <a:p/>
+        </p:txBody>
       </p:sp>
       <p:sp>
         <p:nvSpPr>
@@ -15608,6 +15632,10 @@
             <a:prstDash val="solid"/>
           </a:ln>
         </p:spPr>
+        <p:txBody>
+          <a:bodyPr/>
+          <a:p/>
+        </p:txBody>
       </p:sp>
       <p:sp>
         <p:nvSpPr>
@@ -15644,7 +15672,7 @@
                 <a:ea typeface="Aptos" pitchFamily="34" charset="-122"/>
                 <a:cs typeface="Aptos" pitchFamily="34" charset="-120"/>
               </a:rPr>
-              <a:t>9.7%</a:t>
+              <a:t>{{ACCT3_SHARE}}</a:t>
             </a:r>
             <a:endParaRPr lang="en-US" sz="770" dirty="0"/>
           </a:p>
@@ -15685,7 +15713,7 @@
                 <a:ea typeface="Aptos" pitchFamily="34" charset="-122"/>
                 <a:cs typeface="Aptos" pitchFamily="34" charset="-120"/>
               </a:rPr>
-              <a:t>Maxilub LLC</a:t>
+              <a:t>{{ACCT4_NAME}}</a:t>
             </a:r>
             <a:endParaRPr lang="en-US" sz="800" dirty="0"/>
           </a:p>
@@ -15715,6 +15743,10 @@
             <a:prstDash val="solid"/>
           </a:ln>
         </p:spPr>
+        <p:txBody>
+          <a:bodyPr/>
+          <a:p/>
+        </p:txBody>
       </p:sp>
       <p:sp>
         <p:nvSpPr>
@@ -15740,6 +15772,10 @@
             <a:prstDash val="solid"/>
           </a:ln>
         </p:spPr>
+        <p:txBody>
+          <a:bodyPr/>
+          <a:p/>
+        </p:txBody>
       </p:sp>
       <p:sp>
         <p:nvSpPr>
@@ -15776,7 +15812,7 @@
                 <a:ea typeface="Aptos" pitchFamily="34" charset="-122"/>
                 <a:cs typeface="Aptos" pitchFamily="34" charset="-120"/>
               </a:rPr>
-              <a:t>7.7%</a:t>
+              <a:t>{{ACCT4_SHARE}}</a:t>
             </a:r>
             <a:endParaRPr lang="en-US" sz="770" dirty="0"/>
           </a:p>
@@ -15817,7 +15853,7 @@
                 <a:ea typeface="Aptos" pitchFamily="34" charset="-122"/>
                 <a:cs typeface="Aptos" pitchFamily="34" charset="-120"/>
               </a:rPr>
-              <a:t>Amazon</a:t>
+              <a:t>{{ACCT5_NAME}}</a:t>
             </a:r>
             <a:endParaRPr lang="en-US" sz="800" dirty="0"/>
           </a:p>
@@ -15847,6 +15883,10 @@
             <a:prstDash val="solid"/>
           </a:ln>
         </p:spPr>
+        <p:txBody>
+          <a:bodyPr/>
+          <a:p/>
+        </p:txBody>
       </p:sp>
       <p:sp>
         <p:nvSpPr>
@@ -15872,6 +15912,10 @@
             <a:prstDash val="solid"/>
           </a:ln>
         </p:spPr>
+        <p:txBody>
+          <a:bodyPr/>
+          <a:p/>
+        </p:txBody>
       </p:sp>
       <p:sp>
         <p:nvSpPr>
@@ -15908,7 +15952,7 @@
                 <a:ea typeface="Aptos" pitchFamily="34" charset="-122"/>
                 <a:cs typeface="Aptos" pitchFamily="34" charset="-120"/>
               </a:rPr>
-              <a:t>6.6%</a:t>
+              <a:t>{{ACCT5_SHARE}}</a:t>
             </a:r>
             <a:endParaRPr lang="en-US" sz="770" dirty="0"/>
           </a:p>
@@ -15942,6 +15986,10 @@
             <a:prstDash val="solid"/>
           </a:ln>
         </p:spPr>
+        <p:txBody>
+          <a:bodyPr/>
+          <a:p/>
+        </p:txBody>
       </p:sp>
       <p:sp>
         <p:nvSpPr>
@@ -16128,6 +16176,10 @@
             <a:prstDash val="solid"/>
           </a:ln>
         </p:spPr>
+        <p:txBody>
+          <a:bodyPr/>
+          <a:p/>
+        </p:txBody>
       </p:sp>
       <p:sp>
         <p:nvSpPr>
@@ -16237,6 +16289,10 @@
             <a:prstDash val="solid"/>
           </a:ln>
         </p:spPr>
+        <p:txBody>
+          <a:bodyPr/>
+          <a:p/>
+        </p:txBody>
       </p:sp>
       <p:sp>
         <p:nvSpPr>
@@ -16342,6 +16398,10 @@
             <a:prstDash val="solid"/>
           </a:ln>
         </p:spPr>
+        <p:txBody>
+          <a:bodyPr/>
+          <a:p/>
+        </p:txBody>
       </p:sp>
       <p:sp>
         <p:nvSpPr>

</xml_diff>